<commit_message>
Added clarifications for level switching and submissions in M2
</commit_message>
<xml_diff>
--- a/Week05-06/M2_slides/Lab3_2.pptx
+++ b/Week05-06/M2_slides/Lab3_2.pptx
@@ -212,7 +212,7 @@
           <a:p>
             <a:fld id="{242A57BF-453C-4C2F-B486-4751CBBF0453}" type="datetimeFigureOut">
               <a:rPr lang="en-AU" smtClean="0"/>
-              <a:t>22/08/2025</a:t>
+              <a:t>1/09/2025</a:t>
             </a:fld>
             <a:endParaRPr lang="en-AU"/>
           </a:p>
@@ -1260,7 +1260,7 @@
           <a:p>
             <a:fld id="{1205BC88-DBF0-4610-A802-A09E0A6ECD22}" type="datetimeFigureOut">
               <a:rPr lang="en-AU" smtClean="0"/>
-              <a:t>22/08/2025</a:t>
+              <a:t>1/09/2025</a:t>
             </a:fld>
             <a:endParaRPr lang="en-AU"/>
           </a:p>
@@ -1488,7 +1488,7 @@
           <a:p>
             <a:fld id="{1205BC88-DBF0-4610-A802-A09E0A6ECD22}" type="datetimeFigureOut">
               <a:rPr lang="en-AU" smtClean="0"/>
-              <a:t>22/08/2025</a:t>
+              <a:t>1/09/2025</a:t>
             </a:fld>
             <a:endParaRPr lang="en-AU"/>
           </a:p>
@@ -1668,7 +1668,7 @@
           <a:p>
             <a:fld id="{1205BC88-DBF0-4610-A802-A09E0A6ECD22}" type="datetimeFigureOut">
               <a:rPr lang="en-AU" smtClean="0"/>
-              <a:t>22/08/2025</a:t>
+              <a:t>1/09/2025</a:t>
             </a:fld>
             <a:endParaRPr lang="en-AU"/>
           </a:p>
@@ -1838,7 +1838,7 @@
           <a:p>
             <a:fld id="{1205BC88-DBF0-4610-A802-A09E0A6ECD22}" type="datetimeFigureOut">
               <a:rPr lang="en-AU" smtClean="0"/>
-              <a:t>22/08/2025</a:t>
+              <a:t>1/09/2025</a:t>
             </a:fld>
             <a:endParaRPr lang="en-AU"/>
           </a:p>
@@ -2092,7 +2092,7 @@
           <a:p>
             <a:fld id="{1205BC88-DBF0-4610-A802-A09E0A6ECD22}" type="datetimeFigureOut">
               <a:rPr lang="en-AU" smtClean="0"/>
-              <a:t>22/08/2025</a:t>
+              <a:t>1/09/2025</a:t>
             </a:fld>
             <a:endParaRPr lang="en-AU"/>
           </a:p>
@@ -2418,7 +2418,7 @@
           <a:p>
             <a:fld id="{1205BC88-DBF0-4610-A802-A09E0A6ECD22}" type="datetimeFigureOut">
               <a:rPr lang="en-AU" smtClean="0"/>
-              <a:t>22/08/2025</a:t>
+              <a:t>1/09/2025</a:t>
             </a:fld>
             <a:endParaRPr lang="en-AU"/>
           </a:p>
@@ -2869,7 +2869,7 @@
           <a:p>
             <a:fld id="{1205BC88-DBF0-4610-A802-A09E0A6ECD22}" type="datetimeFigureOut">
               <a:rPr lang="en-AU" smtClean="0"/>
-              <a:t>22/08/2025</a:t>
+              <a:t>1/09/2025</a:t>
             </a:fld>
             <a:endParaRPr lang="en-AU"/>
           </a:p>
@@ -2987,7 +2987,7 @@
           <a:p>
             <a:fld id="{1205BC88-DBF0-4610-A802-A09E0A6ECD22}" type="datetimeFigureOut">
               <a:rPr lang="en-AU" smtClean="0"/>
-              <a:t>22/08/2025</a:t>
+              <a:t>1/09/2025</a:t>
             </a:fld>
             <a:endParaRPr lang="en-AU"/>
           </a:p>
@@ -3082,7 +3082,7 @@
           <a:p>
             <a:fld id="{1205BC88-DBF0-4610-A802-A09E0A6ECD22}" type="datetimeFigureOut">
               <a:rPr lang="en-AU" smtClean="0"/>
-              <a:t>22/08/2025</a:t>
+              <a:t>1/09/2025</a:t>
             </a:fld>
             <a:endParaRPr lang="en-AU"/>
           </a:p>
@@ -3369,7 +3369,7 @@
           <a:p>
             <a:fld id="{1205BC88-DBF0-4610-A802-A09E0A6ECD22}" type="datetimeFigureOut">
               <a:rPr lang="en-AU" smtClean="0"/>
-              <a:t>22/08/2025</a:t>
+              <a:t>1/09/2025</a:t>
             </a:fld>
             <a:endParaRPr lang="en-AU"/>
           </a:p>
@@ -3691,7 +3691,7 @@
           <a:p>
             <a:fld id="{1205BC88-DBF0-4610-A802-A09E0A6ECD22}" type="datetimeFigureOut">
               <a:rPr lang="en-AU" smtClean="0"/>
-              <a:t>22/08/2025</a:t>
+              <a:t>1/09/2025</a:t>
             </a:fld>
             <a:endParaRPr lang="en-AU"/>
           </a:p>
@@ -3945,7 +3945,7 @@
           <a:p>
             <a:fld id="{1205BC88-DBF0-4610-A802-A09E0A6ECD22}" type="datetimeFigureOut">
               <a:rPr lang="en-AU" smtClean="0"/>
-              <a:t>22/08/2025</a:t>
+              <a:t>1/09/2025</a:t>
             </a:fld>
             <a:endParaRPr lang="en-AU"/>
           </a:p>
@@ -8870,7 +8870,7 @@
               </a:rPr>
               <a:t>level_scale</a:t>
             </a:r>
-            <a:endParaRPr lang="en-GB">
+            <a:endParaRPr lang="en-GB" dirty="0">
               <a:solidFill>
                 <a:srgbClr val="FFFF00"/>
               </a:solidFill>
@@ -9078,7 +9078,7 @@
         <p:spPr>
           <a:xfrm>
             <a:off x="478181" y="838376"/>
-            <a:ext cx="8049912" cy="3970318"/>
+            <a:ext cx="8049912" cy="5355312"/>
           </a:xfrm>
           <a:prstGeom prst="rect">
             <a:avLst/>
@@ -9131,13 +9131,8 @@
             </a:pPr>
             <a:r>
               <a:rPr lang="en-US" dirty="0"/>
-              <a:t>Don’t include your training dataset or the python </a:t>
-            </a:r>
-            <a:r>
-              <a:rPr lang="en-US" dirty="0" err="1"/>
-              <a:t>venv</a:t>
-            </a:r>
-            <a:endParaRPr lang="en-US" dirty="0"/>
+              <a:t>Don’t include your training dataset or any python environments</a:t>
+            </a:r>
           </a:p>
           <a:p>
             <a:endParaRPr lang="en-US" dirty="0"/>
@@ -9165,7 +9160,7 @@
             </a:pPr>
             <a:r>
               <a:rPr lang="en-US" dirty="0"/>
-              <a:t>detector visualization (10 testing images, each containing one target object, 2pt for each correct label given)</a:t>
+              <a:t>detector visualization (10 testing images, each containing one target object, 3pt for each correct label given)</a:t>
             </a:r>
           </a:p>
           <a:p>
@@ -9186,6 +9181,47 @@
             <a:r>
               <a:rPr lang="en-US" dirty="0"/>
               <a:t>Submit slam.txt &amp; targets.txt</a:t>
+            </a:r>
+          </a:p>
+          <a:p>
+            <a:pPr marL="742950" lvl="1" indent="-285750">
+              <a:buFont typeface="Arial" panose="020B0604020202020204" pitchFamily="34" charset="0"/>
+              <a:buChar char="•"/>
+            </a:pPr>
+            <a:r>
+              <a:rPr lang="en-US" dirty="0"/>
+              <a:t>You will only be allowed one slam.txt </a:t>
+            </a:r>
+            <a:br>
+              <a:rPr lang="en-US" dirty="0"/>
+            </a:br>
+            <a:r>
+              <a:rPr lang="en-US" dirty="0"/>
+              <a:t>and targets.txt per run</a:t>
+            </a:r>
+          </a:p>
+          <a:p>
+            <a:pPr marL="285750" indent="-285750">
+              <a:buFont typeface="Arial" panose="020B0604020202020204" pitchFamily="34" charset="0"/>
+              <a:buChar char="•"/>
+            </a:pPr>
+            <a:r>
+              <a:rPr lang="en-US" dirty="0"/>
+              <a:t>Switching levels will be included within demo</a:t>
+            </a:r>
+            <a:br>
+              <a:rPr lang="en-US" dirty="0"/>
+            </a:br>
+            <a:r>
+              <a:rPr lang="en-US" dirty="0"/>
+              <a:t>time, so try to limit this to 1-2 level switches</a:t>
+            </a:r>
+            <a:br>
+              <a:rPr lang="en-US" dirty="0"/>
+            </a:br>
+            <a:r>
+              <a:rPr lang="en-US" dirty="0"/>
+              <a:t>max</a:t>
             </a:r>
           </a:p>
         </p:txBody>

</xml_diff>